<commit_message>
Fix forward references to R* labels on survey slides
Slides 3 and 4 appeared before the requirements are defined (slide 5).
Replace R-label references with plain-English equivalents:
- Hash tree candidate: 'satisfies all R1-R10 below' -> 'meets all §4 requirements'
- Barrier 1 arrow: remove 'R1-R10' -> 'must be cryptographic at its core'
- Barrier 2 arrow: 'R6 (public verifiability)' -> 'Public verifiability'
- Barrier 3 arrow: 'R9 eliminates' -> 'post-quantum requirement eliminates'
- Barrier 4 arrow: 'R8 eliminates' -> 'No-trusted-setup eliminates'
</commit_message>
<xml_diff>
--- a/Section4-Requirements-and-Selection.pptx
+++ b/Section4-Requirements-and-Selection.pptx
@@ -5621,7 +5621,7 @@
                   <a:srgbClr val="F0A500"/>
                 </a:solidFill>
               </a:rPr>
-              <a:t>→ THE CANDIDATE  (satisfies all R1–R10 below)</a:t>
+              <a:t>→ THE CANDIDATE  (the only family that meets all §4 requirements)</a:t>
             </a:r>
           </a:p>
         </p:txBody>
@@ -7220,7 +7220,7 @@
               </a:rPr>
               <a:t>CRC, Fletcher, and Adler all admit closed-form corrections.
 An adversary computes a matching tail that preserves the checksum — no brute force needed.
-→  R1–R10 require a cryptographic primitive as the foundation.</a:t>
+→  The integrity primitive must be cryptographic at its core.</a:t>
             </a:r>
           </a:p>
         </p:txBody>
@@ -7410,7 +7410,7 @@
               </a:rPr>
               <a:t>MACs and AEAD are ideal per-chunk tools, but the verifier must hold the key.
 Third-party auditors, archive mirrors, and collaborators cannot verify.
-→  R6 (public verifiability) eliminates any purely symmetric scheme as the root.</a:t>
+→  Public verifiability eliminates any purely symmetric scheme as the root.</a:t>
             </a:r>
           </a:p>
         </p:txBody>
@@ -7600,7 +7600,7 @@
               </a:rPr>
               <a:t>Shor's algorithm breaks ECDSA, Ed25519, RSA, BLS12-381 pairings, and KZG commitments.
 Scientific archives are signed today and verified in 2040–2070.
-→  R9 eliminates Verkle, BLS aggregation, and RSA/bilinear accumulators.</a:t>
+→  The post-quantum requirement eliminates Verkle, BLS aggregation, and RSA/bilinear accumulators.</a:t>
             </a:r>
           </a:p>
         </p:txBody>
@@ -7790,7 +7790,7 @@
               </a:rPr>
               <a:t>KZG, Verkle, and RSA accumulators require an MPC ceremony whose
 parameters must be trusted for the archive's entire lifetime.
-→  R8 eliminates every scheme with a structured reference string.</a:t>
+→  No-trusted-setup eliminates every scheme with a structured reference string.</a:t>
             </a:r>
           </a:p>
         </p:txBody>

</xml_diff>